<commit_message>
Slides: keep the selfHeal field name in its spelling (sd-13-009)
Co-Authored-By: Claude Sonnet 5.5 <noreply@anthropic.com>
Claude-Session: https://claude.ai/code/session_01EhxTYrCJpuk4mcqCLwPdds
</commit_message>
<xml_diff>
--- a/system-design-101/vi/lessons/sd-13-009/slides/sd-13-009.pptx
+++ b/system-design-101/vi/lessons/sd-13-009/slides/sd-13-009.pptx
@@ -8445,7 +8445,7 @@
               <a:t>BẬT</a:t>
             </a:r>
             <a:r>
-              <a:rPr lang="en-US" sz="2250" b="1" spc="224" kern="0" dirty="0">
+              <a:rPr lang="en-US" sz="2250" b="1" spc="221" kern="0" dirty="0">
                 <a:solidFill>
                   <a:srgbClr val="FFB454"/>
                 </a:solidFill>
@@ -8453,7 +8453,7 @@
                 <a:ea typeface="Be Vietnam Pro" pitchFamily="34" charset="-122"/>
                 <a:cs typeface="Be Vietnam Pro" pitchFamily="34" charset="-120"/>
               </a:rPr>
-              <a:t> SELFHEAL</a:t>
+              <a:t> selfHeal</a:t>
             </a:r>
             <a:endParaRPr lang="en-US" sz="2250" dirty="0"/>
           </a:p>

</xml_diff>